<commit_message>
Ažuriran notebook i prezentacija
</commit_message>
<xml_diff>
--- a/Klasifikacija antimikrobnih peptida.pptx
+++ b/Klasifikacija antimikrobnih peptida.pptx
@@ -4,17 +4,21 @@
   <p:sldMasterIdLst>
     <p:sldMasterId id="2147483648" r:id="rId1"/>
   </p:sldMasterIdLst>
+  <p:notesMasterIdLst>
+    <p:notesMasterId r:id="rId13"/>
+  </p:notesMasterIdLst>
   <p:sldIdLst>
     <p:sldId id="256" r:id="rId2"/>
     <p:sldId id="257" r:id="rId3"/>
-    <p:sldId id="258" r:id="rId4"/>
-    <p:sldId id="259" r:id="rId5"/>
-    <p:sldId id="260" r:id="rId6"/>
-    <p:sldId id="261" r:id="rId7"/>
-    <p:sldId id="262" r:id="rId8"/>
-    <p:sldId id="263" r:id="rId9"/>
-    <p:sldId id="264" r:id="rId10"/>
-    <p:sldId id="265" r:id="rId11"/>
+    <p:sldId id="266" r:id="rId4"/>
+    <p:sldId id="258" r:id="rId5"/>
+    <p:sldId id="259" r:id="rId6"/>
+    <p:sldId id="260" r:id="rId7"/>
+    <p:sldId id="261" r:id="rId8"/>
+    <p:sldId id="262" r:id="rId9"/>
+    <p:sldId id="263" r:id="rId10"/>
+    <p:sldId id="264" r:id="rId11"/>
+    <p:sldId id="265" r:id="rId12"/>
   </p:sldIdLst>
   <p:sldSz cx="12192000" cy="6858000"/>
   <p:notesSz cx="6858000" cy="9144000"/>
@@ -113,7 +117,623 @@
       </a:defRPr>
     </a:lvl9pPr>
   </p:defaultTextStyle>
+  <p:extLst>
+    <p:ext uri="{EFAFB233-063F-42B5-8137-9DF3F51BA10A}">
+      <p15:sldGuideLst xmlns:p15="http://schemas.microsoft.com/office/powerpoint/2012/main"/>
+    </p:ext>
+  </p:extLst>
 </p:presentation>
+</file>
+
+<file path=ppt/notesMasters/notesMaster1.xml><?xml version="1.0" encoding="utf-8"?>
+<p:notesMaster xmlns:a="http://schemas.openxmlformats.org/drawingml/2006/main" xmlns:r="http://schemas.openxmlformats.org/officeDocument/2006/relationships" xmlns:p="http://schemas.openxmlformats.org/presentationml/2006/main">
+  <p:cSld>
+    <p:bg>
+      <p:bgRef idx="1001">
+        <a:schemeClr val="bg1"/>
+      </p:bgRef>
+    </p:bg>
+    <p:spTree>
+      <p:nvGrpSpPr>
+        <p:cNvPr id="1" name=""/>
+        <p:cNvGrpSpPr/>
+        <p:nvPr/>
+      </p:nvGrpSpPr>
+      <p:grpSpPr>
+        <a:xfrm>
+          <a:off x="0" y="0"/>
+          <a:ext cx="0" cy="0"/>
+          <a:chOff x="0" y="0"/>
+          <a:chExt cx="0" cy="0"/>
+        </a:xfrm>
+      </p:grpSpPr>
+      <p:sp>
+        <p:nvSpPr>
+          <p:cNvPr id="2" name="Header Placeholder 1"/>
+          <p:cNvSpPr>
+            <a:spLocks noGrp="1"/>
+          </p:cNvSpPr>
+          <p:nvPr>
+            <p:ph type="hdr" sz="quarter"/>
+          </p:nvPr>
+        </p:nvSpPr>
+        <p:spPr>
+          <a:xfrm>
+            <a:off x="0" y="0"/>
+            <a:ext cx="2971800" cy="458788"/>
+          </a:xfrm>
+          <a:prstGeom prst="rect">
+            <a:avLst/>
+          </a:prstGeom>
+        </p:spPr>
+        <p:txBody>
+          <a:bodyPr vert="horz" lIns="91440" tIns="45720" rIns="91440" bIns="45720" rtlCol="0"/>
+          <a:lstStyle>
+            <a:lvl1pPr algn="l">
+              <a:defRPr sz="1200"/>
+            </a:lvl1pPr>
+          </a:lstStyle>
+          <a:p>
+            <a:endParaRPr lang="bs-Latn-BA"/>
+          </a:p>
+        </p:txBody>
+      </p:sp>
+      <p:sp>
+        <p:nvSpPr>
+          <p:cNvPr id="3" name="Date Placeholder 2"/>
+          <p:cNvSpPr>
+            <a:spLocks noGrp="1"/>
+          </p:cNvSpPr>
+          <p:nvPr>
+            <p:ph type="dt" idx="1"/>
+          </p:nvPr>
+        </p:nvSpPr>
+        <p:spPr>
+          <a:xfrm>
+            <a:off x="3884613" y="0"/>
+            <a:ext cx="2971800" cy="458788"/>
+          </a:xfrm>
+          <a:prstGeom prst="rect">
+            <a:avLst/>
+          </a:prstGeom>
+        </p:spPr>
+        <p:txBody>
+          <a:bodyPr vert="horz" lIns="91440" tIns="45720" rIns="91440" bIns="45720" rtlCol="0"/>
+          <a:lstStyle>
+            <a:lvl1pPr algn="r">
+              <a:defRPr sz="1200"/>
+            </a:lvl1pPr>
+          </a:lstStyle>
+          <a:p>
+            <a:fld id="{D4D05F32-D78A-4E1F-B2F3-65342D9B1B9D}" type="datetimeFigureOut">
+              <a:rPr lang="bs-Latn-BA" smtClean="0"/>
+              <a:t>26. 6. 2026.</a:t>
+            </a:fld>
+            <a:endParaRPr lang="bs-Latn-BA"/>
+          </a:p>
+        </p:txBody>
+      </p:sp>
+      <p:sp>
+        <p:nvSpPr>
+          <p:cNvPr id="4" name="Slide Image Placeholder 3"/>
+          <p:cNvSpPr>
+            <a:spLocks noGrp="1" noRot="1" noChangeAspect="1"/>
+          </p:cNvSpPr>
+          <p:nvPr>
+            <p:ph type="sldImg" idx="2"/>
+          </p:nvPr>
+        </p:nvSpPr>
+        <p:spPr>
+          <a:xfrm>
+            <a:off x="685800" y="1143000"/>
+            <a:ext cx="5486400" cy="3086100"/>
+          </a:xfrm>
+          <a:prstGeom prst="rect">
+            <a:avLst/>
+          </a:prstGeom>
+          <a:noFill/>
+          <a:ln w="12700">
+            <a:solidFill>
+              <a:prstClr val="black"/>
+            </a:solidFill>
+          </a:ln>
+        </p:spPr>
+        <p:txBody>
+          <a:bodyPr vert="horz" lIns="91440" tIns="45720" rIns="91440" bIns="45720" rtlCol="0" anchor="ctr"/>
+          <a:lstStyle/>
+          <a:p>
+            <a:endParaRPr lang="bs-Latn-BA"/>
+          </a:p>
+        </p:txBody>
+      </p:sp>
+      <p:sp>
+        <p:nvSpPr>
+          <p:cNvPr id="5" name="Notes Placeholder 4"/>
+          <p:cNvSpPr>
+            <a:spLocks noGrp="1"/>
+          </p:cNvSpPr>
+          <p:nvPr>
+            <p:ph type="body" sz="quarter" idx="3"/>
+          </p:nvPr>
+        </p:nvSpPr>
+        <p:spPr>
+          <a:xfrm>
+            <a:off x="685800" y="4400550"/>
+            <a:ext cx="5486400" cy="3600450"/>
+          </a:xfrm>
+          <a:prstGeom prst="rect">
+            <a:avLst/>
+          </a:prstGeom>
+        </p:spPr>
+        <p:txBody>
+          <a:bodyPr vert="horz" lIns="91440" tIns="45720" rIns="91440" bIns="45720" rtlCol="0"/>
+          <a:lstStyle/>
+          <a:p>
+            <a:pPr lvl="0"/>
+            <a:r>
+              <a:rPr lang="en-US"/>
+              <a:t>Click to edit Master text styles</a:t>
+            </a:r>
+          </a:p>
+          <a:p>
+            <a:pPr lvl="1"/>
+            <a:r>
+              <a:rPr lang="en-US"/>
+              <a:t>Second level</a:t>
+            </a:r>
+          </a:p>
+          <a:p>
+            <a:pPr lvl="2"/>
+            <a:r>
+              <a:rPr lang="en-US"/>
+              <a:t>Third level</a:t>
+            </a:r>
+          </a:p>
+          <a:p>
+            <a:pPr lvl="3"/>
+            <a:r>
+              <a:rPr lang="en-US"/>
+              <a:t>Fourth level</a:t>
+            </a:r>
+          </a:p>
+          <a:p>
+            <a:pPr lvl="4"/>
+            <a:r>
+              <a:rPr lang="en-US"/>
+              <a:t>Fifth level</a:t>
+            </a:r>
+            <a:endParaRPr lang="bs-Latn-BA"/>
+          </a:p>
+        </p:txBody>
+      </p:sp>
+      <p:sp>
+        <p:nvSpPr>
+          <p:cNvPr id="6" name="Footer Placeholder 5"/>
+          <p:cNvSpPr>
+            <a:spLocks noGrp="1"/>
+          </p:cNvSpPr>
+          <p:nvPr>
+            <p:ph type="ftr" sz="quarter" idx="4"/>
+          </p:nvPr>
+        </p:nvSpPr>
+        <p:spPr>
+          <a:xfrm>
+            <a:off x="0" y="8685213"/>
+            <a:ext cx="2971800" cy="458787"/>
+          </a:xfrm>
+          <a:prstGeom prst="rect">
+            <a:avLst/>
+          </a:prstGeom>
+        </p:spPr>
+        <p:txBody>
+          <a:bodyPr vert="horz" lIns="91440" tIns="45720" rIns="91440" bIns="45720" rtlCol="0" anchor="b"/>
+          <a:lstStyle>
+            <a:lvl1pPr algn="l">
+              <a:defRPr sz="1200"/>
+            </a:lvl1pPr>
+          </a:lstStyle>
+          <a:p>
+            <a:endParaRPr lang="bs-Latn-BA"/>
+          </a:p>
+        </p:txBody>
+      </p:sp>
+      <p:sp>
+        <p:nvSpPr>
+          <p:cNvPr id="7" name="Slide Number Placeholder 6"/>
+          <p:cNvSpPr>
+            <a:spLocks noGrp="1"/>
+          </p:cNvSpPr>
+          <p:nvPr>
+            <p:ph type="sldNum" sz="quarter" idx="5"/>
+          </p:nvPr>
+        </p:nvSpPr>
+        <p:spPr>
+          <a:xfrm>
+            <a:off x="3884613" y="8685213"/>
+            <a:ext cx="2971800" cy="458787"/>
+          </a:xfrm>
+          <a:prstGeom prst="rect">
+            <a:avLst/>
+          </a:prstGeom>
+        </p:spPr>
+        <p:txBody>
+          <a:bodyPr vert="horz" lIns="91440" tIns="45720" rIns="91440" bIns="45720" rtlCol="0" anchor="b"/>
+          <a:lstStyle>
+            <a:lvl1pPr algn="r">
+              <a:defRPr sz="1200"/>
+            </a:lvl1pPr>
+          </a:lstStyle>
+          <a:p>
+            <a:fld id="{F6C06B9C-569B-4D47-9A3F-D8CFD8AF2F39}" type="slidenum">
+              <a:rPr lang="bs-Latn-BA" smtClean="0"/>
+              <a:t>‹#›</a:t>
+            </a:fld>
+            <a:endParaRPr lang="bs-Latn-BA"/>
+          </a:p>
+        </p:txBody>
+      </p:sp>
+    </p:spTree>
+    <p:extLst>
+      <p:ext uri="{BB962C8B-B14F-4D97-AF65-F5344CB8AC3E}">
+        <p14:creationId xmlns:p14="http://schemas.microsoft.com/office/powerpoint/2010/main" val="2216912446"/>
+      </p:ext>
+    </p:extLst>
+  </p:cSld>
+  <p:clrMap bg1="lt1" tx1="dk1" bg2="lt2" tx2="dk2" accent1="accent1" accent2="accent2" accent3="accent3" accent4="accent4" accent5="accent5" accent6="accent6" hlink="hlink" folHlink="folHlink"/>
+  <p:notesStyle>
+    <a:lvl1pPr marL="0" algn="l" defTabSz="914400" rtl="0" eaLnBrk="1" latinLnBrk="0" hangingPunct="1">
+      <a:defRPr sz="1200" kern="1200">
+        <a:solidFill>
+          <a:schemeClr val="tx1"/>
+        </a:solidFill>
+        <a:latin typeface="+mn-lt"/>
+        <a:ea typeface="+mn-ea"/>
+        <a:cs typeface="+mn-cs"/>
+      </a:defRPr>
+    </a:lvl1pPr>
+    <a:lvl2pPr marL="457200" algn="l" defTabSz="914400" rtl="0" eaLnBrk="1" latinLnBrk="0" hangingPunct="1">
+      <a:defRPr sz="1200" kern="1200">
+        <a:solidFill>
+          <a:schemeClr val="tx1"/>
+        </a:solidFill>
+        <a:latin typeface="+mn-lt"/>
+        <a:ea typeface="+mn-ea"/>
+        <a:cs typeface="+mn-cs"/>
+      </a:defRPr>
+    </a:lvl2pPr>
+    <a:lvl3pPr marL="914400" algn="l" defTabSz="914400" rtl="0" eaLnBrk="1" latinLnBrk="0" hangingPunct="1">
+      <a:defRPr sz="1200" kern="1200">
+        <a:solidFill>
+          <a:schemeClr val="tx1"/>
+        </a:solidFill>
+        <a:latin typeface="+mn-lt"/>
+        <a:ea typeface="+mn-ea"/>
+        <a:cs typeface="+mn-cs"/>
+      </a:defRPr>
+    </a:lvl3pPr>
+    <a:lvl4pPr marL="1371600" algn="l" defTabSz="914400" rtl="0" eaLnBrk="1" latinLnBrk="0" hangingPunct="1">
+      <a:defRPr sz="1200" kern="1200">
+        <a:solidFill>
+          <a:schemeClr val="tx1"/>
+        </a:solidFill>
+        <a:latin typeface="+mn-lt"/>
+        <a:ea typeface="+mn-ea"/>
+        <a:cs typeface="+mn-cs"/>
+      </a:defRPr>
+    </a:lvl4pPr>
+    <a:lvl5pPr marL="1828800" algn="l" defTabSz="914400" rtl="0" eaLnBrk="1" latinLnBrk="0" hangingPunct="1">
+      <a:defRPr sz="1200" kern="1200">
+        <a:solidFill>
+          <a:schemeClr val="tx1"/>
+        </a:solidFill>
+        <a:latin typeface="+mn-lt"/>
+        <a:ea typeface="+mn-ea"/>
+        <a:cs typeface="+mn-cs"/>
+      </a:defRPr>
+    </a:lvl5pPr>
+    <a:lvl6pPr marL="2286000" algn="l" defTabSz="914400" rtl="0" eaLnBrk="1" latinLnBrk="0" hangingPunct="1">
+      <a:defRPr sz="1200" kern="1200">
+        <a:solidFill>
+          <a:schemeClr val="tx1"/>
+        </a:solidFill>
+        <a:latin typeface="+mn-lt"/>
+        <a:ea typeface="+mn-ea"/>
+        <a:cs typeface="+mn-cs"/>
+      </a:defRPr>
+    </a:lvl6pPr>
+    <a:lvl7pPr marL="2743200" algn="l" defTabSz="914400" rtl="0" eaLnBrk="1" latinLnBrk="0" hangingPunct="1">
+      <a:defRPr sz="1200" kern="1200">
+        <a:solidFill>
+          <a:schemeClr val="tx1"/>
+        </a:solidFill>
+        <a:latin typeface="+mn-lt"/>
+        <a:ea typeface="+mn-ea"/>
+        <a:cs typeface="+mn-cs"/>
+      </a:defRPr>
+    </a:lvl7pPr>
+    <a:lvl8pPr marL="3200400" algn="l" defTabSz="914400" rtl="0" eaLnBrk="1" latinLnBrk="0" hangingPunct="1">
+      <a:defRPr sz="1200" kern="1200">
+        <a:solidFill>
+          <a:schemeClr val="tx1"/>
+        </a:solidFill>
+        <a:latin typeface="+mn-lt"/>
+        <a:ea typeface="+mn-ea"/>
+        <a:cs typeface="+mn-cs"/>
+      </a:defRPr>
+    </a:lvl8pPr>
+    <a:lvl9pPr marL="3657600" algn="l" defTabSz="914400" rtl="0" eaLnBrk="1" latinLnBrk="0" hangingPunct="1">
+      <a:defRPr sz="1200" kern="1200">
+        <a:solidFill>
+          <a:schemeClr val="tx1"/>
+        </a:solidFill>
+        <a:latin typeface="+mn-lt"/>
+        <a:ea typeface="+mn-ea"/>
+        <a:cs typeface="+mn-cs"/>
+      </a:defRPr>
+    </a:lvl9pPr>
+  </p:notesStyle>
+</p:notesMaster>
+</file>
+
+<file path=ppt/notesSlides/notesSlide1.xml><?xml version="1.0" encoding="utf-8"?>
+<p:notes xmlns:a="http://schemas.openxmlformats.org/drawingml/2006/main" xmlns:r="http://schemas.openxmlformats.org/officeDocument/2006/relationships" xmlns:p="http://schemas.openxmlformats.org/presentationml/2006/main">
+  <p:cSld>
+    <p:spTree>
+      <p:nvGrpSpPr>
+        <p:cNvPr id="1" name=""/>
+        <p:cNvGrpSpPr/>
+        <p:nvPr/>
+      </p:nvGrpSpPr>
+      <p:grpSpPr>
+        <a:xfrm>
+          <a:off x="0" y="0"/>
+          <a:ext cx="0" cy="0"/>
+          <a:chOff x="0" y="0"/>
+          <a:chExt cx="0" cy="0"/>
+        </a:xfrm>
+      </p:grpSpPr>
+      <p:sp>
+        <p:nvSpPr>
+          <p:cNvPr id="2" name="Slide Image Placeholder 1"/>
+          <p:cNvSpPr>
+            <a:spLocks noGrp="1" noRot="1" noChangeAspect="1"/>
+          </p:cNvSpPr>
+          <p:nvPr>
+            <p:ph type="sldImg"/>
+          </p:nvPr>
+        </p:nvSpPr>
+        <p:spPr/>
+      </p:sp>
+      <p:sp>
+        <p:nvSpPr>
+          <p:cNvPr id="3" name="Notes Placeholder 2"/>
+          <p:cNvSpPr>
+            <a:spLocks noGrp="1"/>
+          </p:cNvSpPr>
+          <p:nvPr>
+            <p:ph type="body" idx="1"/>
+          </p:nvPr>
+        </p:nvSpPr>
+        <p:spPr/>
+        <p:txBody>
+          <a:bodyPr/>
+          <a:lstStyle/>
+          <a:p>
+            <a:r>
+              <a:rPr lang="bs-Latn-BA" dirty="0"/>
+              <a:t>Dobar dan. Ja sam Ana Ljubić i u ovom projektu bavila sam se klasifikacijom antimikrobnih peptida primjenom metoda strojnog učenja. Tijekom prezentacije prikazat ću problem koji se rješava, korištene podatke, bioinformatičke značajke, modele strojnog učenja te rezultate koje sam dobila.</a:t>
+            </a:r>
+          </a:p>
+        </p:txBody>
+      </p:sp>
+      <p:sp>
+        <p:nvSpPr>
+          <p:cNvPr id="4" name="Slide Number Placeholder 3"/>
+          <p:cNvSpPr>
+            <a:spLocks noGrp="1"/>
+          </p:cNvSpPr>
+          <p:nvPr>
+            <p:ph type="sldNum" sz="quarter" idx="5"/>
+          </p:nvPr>
+        </p:nvSpPr>
+        <p:spPr/>
+        <p:txBody>
+          <a:bodyPr/>
+          <a:lstStyle/>
+          <a:p>
+            <a:fld id="{F6C06B9C-569B-4D47-9A3F-D8CFD8AF2F39}" type="slidenum">
+              <a:rPr lang="bs-Latn-BA" smtClean="0"/>
+              <a:t>1</a:t>
+            </a:fld>
+            <a:endParaRPr lang="bs-Latn-BA"/>
+          </a:p>
+        </p:txBody>
+      </p:sp>
+    </p:spTree>
+    <p:extLst>
+      <p:ext uri="{BB962C8B-B14F-4D97-AF65-F5344CB8AC3E}">
+        <p14:creationId xmlns:p14="http://schemas.microsoft.com/office/powerpoint/2010/main" val="3967889018"/>
+      </p:ext>
+    </p:extLst>
+  </p:cSld>
+  <p:clrMapOvr>
+    <a:masterClrMapping/>
+  </p:clrMapOvr>
+</p:notes>
+</file>
+
+<file path=ppt/notesSlides/notesSlide2.xml><?xml version="1.0" encoding="utf-8"?>
+<p:notes xmlns:a="http://schemas.openxmlformats.org/drawingml/2006/main" xmlns:r="http://schemas.openxmlformats.org/officeDocument/2006/relationships" xmlns:p="http://schemas.openxmlformats.org/presentationml/2006/main">
+  <p:cSld>
+    <p:spTree>
+      <p:nvGrpSpPr>
+        <p:cNvPr id="1" name=""/>
+        <p:cNvGrpSpPr/>
+        <p:nvPr/>
+      </p:nvGrpSpPr>
+      <p:grpSpPr>
+        <a:xfrm>
+          <a:off x="0" y="0"/>
+          <a:ext cx="0" cy="0"/>
+          <a:chOff x="0" y="0"/>
+          <a:chExt cx="0" cy="0"/>
+        </a:xfrm>
+      </p:grpSpPr>
+      <p:sp>
+        <p:nvSpPr>
+          <p:cNvPr id="2" name="Slide Image Placeholder 1"/>
+          <p:cNvSpPr>
+            <a:spLocks noGrp="1" noRot="1" noChangeAspect="1"/>
+          </p:cNvSpPr>
+          <p:nvPr>
+            <p:ph type="sldImg"/>
+          </p:nvPr>
+        </p:nvSpPr>
+        <p:spPr/>
+      </p:sp>
+      <p:sp>
+        <p:nvSpPr>
+          <p:cNvPr id="3" name="Notes Placeholder 2"/>
+          <p:cNvSpPr>
+            <a:spLocks noGrp="1"/>
+          </p:cNvSpPr>
+          <p:nvPr>
+            <p:ph type="body" idx="1"/>
+          </p:nvPr>
+        </p:nvSpPr>
+        <p:spPr/>
+        <p:txBody>
+          <a:bodyPr/>
+          <a:lstStyle/>
+          <a:p>
+            <a:r>
+              <a:rPr lang="bs-Latn-BA" dirty="0"/>
+              <a:t>Prezentacija je podijeljena u šest cjelina. Najprije ću objasniti motivaciju i cilj projekta, zatim opisati korištene skupove podataka i bioinformatičke značajke. Nakon toga prikazat ću modele strojnog učenja, rezultate evaluacije te na kraju iznijeti zaključak.</a:t>
+            </a:r>
+          </a:p>
+        </p:txBody>
+      </p:sp>
+      <p:sp>
+        <p:nvSpPr>
+          <p:cNvPr id="4" name="Slide Number Placeholder 3"/>
+          <p:cNvSpPr>
+            <a:spLocks noGrp="1"/>
+          </p:cNvSpPr>
+          <p:nvPr>
+            <p:ph type="sldNum" sz="quarter" idx="5"/>
+          </p:nvPr>
+        </p:nvSpPr>
+        <p:spPr/>
+        <p:txBody>
+          <a:bodyPr/>
+          <a:lstStyle/>
+          <a:p>
+            <a:fld id="{F6C06B9C-569B-4D47-9A3F-D8CFD8AF2F39}" type="slidenum">
+              <a:rPr lang="bs-Latn-BA" smtClean="0"/>
+              <a:t>2</a:t>
+            </a:fld>
+            <a:endParaRPr lang="bs-Latn-BA"/>
+          </a:p>
+        </p:txBody>
+      </p:sp>
+    </p:spTree>
+    <p:extLst>
+      <p:ext uri="{BB962C8B-B14F-4D97-AF65-F5344CB8AC3E}">
+        <p14:creationId xmlns:p14="http://schemas.microsoft.com/office/powerpoint/2010/main" val="804315959"/>
+      </p:ext>
+    </p:extLst>
+  </p:cSld>
+  <p:clrMapOvr>
+    <a:masterClrMapping/>
+  </p:clrMapOvr>
+</p:notes>
+</file>
+
+<file path=ppt/notesSlides/notesSlide3.xml><?xml version="1.0" encoding="utf-8"?>
+<p:notes xmlns:a="http://schemas.openxmlformats.org/drawingml/2006/main" xmlns:r="http://schemas.openxmlformats.org/officeDocument/2006/relationships" xmlns:p="http://schemas.openxmlformats.org/presentationml/2006/main">
+  <p:cSld>
+    <p:spTree>
+      <p:nvGrpSpPr>
+        <p:cNvPr id="1" name=""/>
+        <p:cNvGrpSpPr/>
+        <p:nvPr/>
+      </p:nvGrpSpPr>
+      <p:grpSpPr>
+        <a:xfrm>
+          <a:off x="0" y="0"/>
+          <a:ext cx="0" cy="0"/>
+          <a:chOff x="0" y="0"/>
+          <a:chExt cx="0" cy="0"/>
+        </a:xfrm>
+      </p:grpSpPr>
+      <p:sp>
+        <p:nvSpPr>
+          <p:cNvPr id="2" name="Slide Image Placeholder 1"/>
+          <p:cNvSpPr>
+            <a:spLocks noGrp="1" noRot="1" noChangeAspect="1"/>
+          </p:cNvSpPr>
+          <p:nvPr>
+            <p:ph type="sldImg"/>
+          </p:nvPr>
+        </p:nvSpPr>
+        <p:spPr/>
+      </p:sp>
+      <p:sp>
+        <p:nvSpPr>
+          <p:cNvPr id="3" name="Notes Placeholder 2"/>
+          <p:cNvSpPr>
+            <a:spLocks noGrp="1"/>
+          </p:cNvSpPr>
+          <p:nvPr>
+            <p:ph type="body" idx="1"/>
+          </p:nvPr>
+        </p:nvSpPr>
+        <p:spPr/>
+        <p:txBody>
+          <a:bodyPr/>
+          <a:lstStyle/>
+          <a:p>
+            <a:r>
+              <a:rPr lang="bs-Latn-BA" dirty="0"/>
+              <a:t>Razlog odabira ove teme je sve veća otpornost bakterija na postojeće antibiotike. Antimikrobni peptidi predstavljaju prirodne molekule koje mogu djelovati protiv bakterija, gljivica i drugih mikroorganizama. Cilj projekta bio je razviti model strojnog učenja koji će na temelju bioinformatičkih značajki razlikovati antimikrobne od neantimikrobnih peptida.</a:t>
+            </a:r>
+          </a:p>
+        </p:txBody>
+      </p:sp>
+      <p:sp>
+        <p:nvSpPr>
+          <p:cNvPr id="4" name="Slide Number Placeholder 3"/>
+          <p:cNvSpPr>
+            <a:spLocks noGrp="1"/>
+          </p:cNvSpPr>
+          <p:nvPr>
+            <p:ph type="sldNum" sz="quarter" idx="5"/>
+          </p:nvPr>
+        </p:nvSpPr>
+        <p:spPr/>
+        <p:txBody>
+          <a:bodyPr/>
+          <a:lstStyle/>
+          <a:p>
+            <a:fld id="{F6C06B9C-569B-4D47-9A3F-D8CFD8AF2F39}" type="slidenum">
+              <a:rPr lang="bs-Latn-BA" smtClean="0"/>
+              <a:t>3</a:t>
+            </a:fld>
+            <a:endParaRPr lang="bs-Latn-BA"/>
+          </a:p>
+        </p:txBody>
+      </p:sp>
+    </p:spTree>
+    <p:extLst>
+      <p:ext uri="{BB962C8B-B14F-4D97-AF65-F5344CB8AC3E}">
+        <p14:creationId xmlns:p14="http://schemas.microsoft.com/office/powerpoint/2010/main" val="1630053099"/>
+      </p:ext>
+    </p:extLst>
+  </p:cSld>
+  <p:clrMapOvr>
+    <a:masterClrMapping/>
+  </p:clrMapOvr>
+</p:notes>
 </file>
 
 <file path=ppt/slideLayouts/slideLayout1.xml><?xml version="1.0" encoding="utf-8"?>
@@ -3378,10 +3998,22 @@
           <a:lstStyle/>
           <a:p>
             <a:r>
-              <a:rPr lang="sv-SE" dirty="0"/>
+              <a:rPr lang="sv-SE" sz="3400" dirty="0">
+                <a:solidFill>
+                  <a:schemeClr val="accent1">
+                    <a:lumMod val="50000"/>
+                  </a:schemeClr>
+                </a:solidFill>
+              </a:rPr>
               <a:t>Klasifikacija antimikrobnih peptida</a:t>
             </a:r>
-            <a:endParaRPr lang="bs-Latn-BA" dirty="0"/>
+            <a:endParaRPr lang="bs-Latn-BA" sz="3400" dirty="0">
+              <a:solidFill>
+                <a:schemeClr val="accent1">
+                  <a:lumMod val="50000"/>
+                </a:schemeClr>
+              </a:solidFill>
+            </a:endParaRPr>
           </a:p>
         </p:txBody>
       </p:sp>
@@ -3403,28 +4035,63 @@
         </p:nvSpPr>
         <p:spPr/>
         <p:txBody>
-          <a:bodyPr/>
+          <a:bodyPr>
+            <a:normAutofit/>
+          </a:bodyPr>
+          <a:lstStyle/>
+          <a:p>
+            <a:r>
+              <a:rPr lang="bs-Latn-BA" sz="2200" dirty="0"/>
+              <a:t>Ana Ljubić</a:t>
+            </a:r>
+          </a:p>
+          <a:p>
+            <a:endParaRPr lang="bs-Latn-BA" sz="2200" dirty="0"/>
+          </a:p>
+        </p:txBody>
+      </p:sp>
+      <p:sp>
+        <p:nvSpPr>
+          <p:cNvPr id="8" name="TextBox 7">
+            <a:extLst>
+              <a:ext uri="{FF2B5EF4-FFF2-40B4-BE49-F238E27FC236}">
+                <a16:creationId xmlns:a16="http://schemas.microsoft.com/office/drawing/2014/main" id="{1F49AE84-27E2-40D9-8F97-556CE28A3282}"/>
+              </a:ext>
+            </a:extLst>
+          </p:cNvPr>
+          <p:cNvSpPr txBox="1"/>
+          <p:nvPr/>
+        </p:nvSpPr>
+        <p:spPr>
+          <a:xfrm>
+            <a:off x="1646500" y="6048697"/>
+            <a:ext cx="6094070" cy="646331"/>
+          </a:xfrm>
+          <a:prstGeom prst="rect">
+            <a:avLst/>
+          </a:prstGeom>
+          <a:noFill/>
+        </p:spPr>
+        <p:txBody>
+          <a:bodyPr wrap="square">
+            <a:spAutoFit/>
+          </a:bodyPr>
           <a:lstStyle/>
           <a:p>
             <a:r>
               <a:rPr lang="bs-Latn-BA" dirty="0"/>
-              <a:t>Ana Ljubić</a:t>
-            </a:r>
-          </a:p>
-          <a:p>
-            <a:r>
-              <a:rPr lang="bs-Latn-BA" dirty="0"/>
+              <a:t>Kolegij: </a:t>
+            </a:r>
+            <a:r>
+              <a:rPr lang="bs-Latn-BA" sz="1800" dirty="0"/>
               <a:t>Bioinformatika</a:t>
             </a:r>
           </a:p>
           <a:p>
             <a:r>
-              <a:rPr lang="bs-Latn-BA" dirty="0"/>
+              <a:rPr lang="bs-Latn-BA" sz="1800" dirty="0"/>
               <a:t>Sveučilište u Mostaru</a:t>
             </a:r>
-          </a:p>
-          <a:p>
-            <a:endParaRPr lang="bs-Latn-BA" dirty="0"/>
           </a:p>
         </p:txBody>
       </p:sp>
@@ -3463,6 +4130,195 @@
           <p:cNvPr id="2" name="Title 1">
             <a:extLst>
               <a:ext uri="{FF2B5EF4-FFF2-40B4-BE49-F238E27FC236}">
+                <a16:creationId xmlns:a16="http://schemas.microsoft.com/office/drawing/2014/main" id="{99F40CC0-509D-401D-8390-D9C19BC73821}"/>
+              </a:ext>
+            </a:extLst>
+          </p:cNvPr>
+          <p:cNvSpPr>
+            <a:spLocks noGrp="1"/>
+          </p:cNvSpPr>
+          <p:nvPr>
+            <p:ph type="title"/>
+          </p:nvPr>
+        </p:nvSpPr>
+        <p:spPr/>
+        <p:txBody>
+          <a:bodyPr/>
+          <a:lstStyle/>
+          <a:p>
+            <a:r>
+              <a:rPr lang="bs-Latn-BA" dirty="0"/>
+              <a:t>Zaključak</a:t>
+            </a:r>
+          </a:p>
+        </p:txBody>
+      </p:sp>
+      <p:sp>
+        <p:nvSpPr>
+          <p:cNvPr id="12" name="Content Placeholder 11">
+            <a:extLst>
+              <a:ext uri="{FF2B5EF4-FFF2-40B4-BE49-F238E27FC236}">
+                <a16:creationId xmlns:a16="http://schemas.microsoft.com/office/drawing/2014/main" id="{9352BE13-6B85-49AC-9FE3-0EFAF02B6A25}"/>
+              </a:ext>
+            </a:extLst>
+          </p:cNvPr>
+          <p:cNvSpPr>
+            <a:spLocks noGrp="1"/>
+          </p:cNvSpPr>
+          <p:nvPr>
+            <p:ph sz="half" idx="1"/>
+          </p:nvPr>
+        </p:nvSpPr>
+        <p:spPr/>
+        <p:txBody>
+          <a:bodyPr/>
+          <a:lstStyle/>
+          <a:p>
+            <a:r>
+              <a:rPr lang="bs-Latn-BA" sz="1800" b="1" dirty="0">
+                <a:effectLst/>
+                <a:latin typeface="Calibri" panose="020F0502020204030204" pitchFamily="34" charset="0"/>
+                <a:ea typeface="Calibri" panose="020F0502020204030204" pitchFamily="34" charset="0"/>
+                <a:cs typeface="Times New Roman" panose="02020603050405020304" pitchFamily="18" charset="0"/>
+              </a:rPr>
+              <a:t>Za kraj mogu zaključiti da je cilj ovog projekta uspješno ostvaren. Razvila sam model strojnog učenja koji razlikuje antimikrobne od neantimikrobnih peptida na temelju bioinformatičkih značajki. Oba modela ostvarila su vrlo dobre rezultate, dok je Random Forest bio nešto uspješniji od SVM-a. Analiza važnosti značajki pokazala je da je neto naboj najvažnije svojstvo za klasifikaciju peptida. U budućnosti bi se projekt mogao proširiti korištenjem dodatnih bioinformatičkih značajki ili naprednijih modela strojnog učenja."</a:t>
+            </a:r>
+            <a:endParaRPr lang="bs-Latn-BA" dirty="0"/>
+          </a:p>
+        </p:txBody>
+      </p:sp>
+      <p:sp>
+        <p:nvSpPr>
+          <p:cNvPr id="4" name="Content Placeholder 3">
+            <a:extLst>
+              <a:ext uri="{FF2B5EF4-FFF2-40B4-BE49-F238E27FC236}">
+                <a16:creationId xmlns:a16="http://schemas.microsoft.com/office/drawing/2014/main" id="{91457B41-5DFC-4D11-8F7C-B3DE3045429F}"/>
+              </a:ext>
+            </a:extLst>
+          </p:cNvPr>
+          <p:cNvSpPr>
+            <a:spLocks noGrp="1"/>
+          </p:cNvSpPr>
+          <p:nvPr>
+            <p:ph sz="half" idx="2"/>
+          </p:nvPr>
+        </p:nvSpPr>
+        <p:spPr/>
+        <p:txBody>
+          <a:bodyPr/>
+          <a:lstStyle/>
+          <a:p>
+            <a:pPr marL="342900" lvl="0" indent="-342900">
+              <a:buSzPts val="1000"/>
+              <a:buFont typeface="Symbol" panose="05050102010706020507" pitchFamily="18" charset="2"/>
+              <a:buChar char=""/>
+              <a:tabLst>
+                <a:tab pos="457200" algn="l"/>
+              </a:tabLst>
+            </a:pPr>
+            <a:r>
+              <a:rPr lang="bs-Latn-BA" sz="1800" dirty="0">
+                <a:effectLst/>
+                <a:latin typeface="Times New Roman" panose="02020603050405020304" pitchFamily="18" charset="0"/>
+                <a:ea typeface="Times New Roman" panose="02020603050405020304" pitchFamily="18" charset="0"/>
+              </a:rPr>
+              <a:t>Razvijen model za klasifikaciju AMP i non-AMP peptida</a:t>
+            </a:r>
+          </a:p>
+          <a:p>
+            <a:pPr marL="342900" lvl="0" indent="-342900">
+              <a:buSzPts val="1000"/>
+              <a:buFont typeface="Symbol" panose="05050102010706020507" pitchFamily="18" charset="2"/>
+              <a:buChar char=""/>
+              <a:tabLst>
+                <a:tab pos="457200" algn="l"/>
+              </a:tabLst>
+            </a:pPr>
+            <a:r>
+              <a:rPr lang="bs-Latn-BA" sz="1800" dirty="0">
+                <a:effectLst/>
+                <a:latin typeface="Times New Roman" panose="02020603050405020304" pitchFamily="18" charset="0"/>
+                <a:ea typeface="Times New Roman" panose="02020603050405020304" pitchFamily="18" charset="0"/>
+              </a:rPr>
+              <a:t>Random Forest ostvario najbolje rezultate</a:t>
+            </a:r>
+          </a:p>
+          <a:p>
+            <a:pPr marL="342900" lvl="0" indent="-342900">
+              <a:buSzPts val="1000"/>
+              <a:buFont typeface="Symbol" panose="05050102010706020507" pitchFamily="18" charset="2"/>
+              <a:buChar char=""/>
+              <a:tabLst>
+                <a:tab pos="457200" algn="l"/>
+              </a:tabLst>
+            </a:pPr>
+            <a:r>
+              <a:rPr lang="bs-Latn-BA" sz="1800" dirty="0">
+                <a:effectLst/>
+                <a:latin typeface="Times New Roman" panose="02020603050405020304" pitchFamily="18" charset="0"/>
+                <a:ea typeface="Times New Roman" panose="02020603050405020304" pitchFamily="18" charset="0"/>
+              </a:rPr>
+              <a:t>Neto naboj bio najvažnija značajka</a:t>
+            </a:r>
+          </a:p>
+          <a:p>
+            <a:pPr marL="342900" lvl="0" indent="-342900">
+              <a:buSzPts val="1000"/>
+              <a:buFont typeface="Symbol" panose="05050102010706020507" pitchFamily="18" charset="2"/>
+              <a:buChar char=""/>
+              <a:tabLst>
+                <a:tab pos="457200" algn="l"/>
+              </a:tabLst>
+            </a:pPr>
+            <a:r>
+              <a:rPr lang="bs-Latn-BA" sz="1800" dirty="0">
+                <a:effectLst/>
+                <a:latin typeface="Times New Roman" panose="02020603050405020304" pitchFamily="18" charset="0"/>
+                <a:ea typeface="Times New Roman" panose="02020603050405020304" pitchFamily="18" charset="0"/>
+              </a:rPr>
+              <a:t>Mogućnost proširenja dodatnim značajkama i modelima</a:t>
+            </a:r>
+          </a:p>
+          <a:p>
+            <a:endParaRPr lang="bs-Latn-BA" dirty="0"/>
+          </a:p>
+        </p:txBody>
+      </p:sp>
+    </p:spTree>
+    <p:extLst>
+      <p:ext uri="{BB962C8B-B14F-4D97-AF65-F5344CB8AC3E}">
+        <p14:creationId xmlns:p14="http://schemas.microsoft.com/office/powerpoint/2010/main" val="3231986733"/>
+      </p:ext>
+    </p:extLst>
+  </p:cSld>
+  <p:clrMapOvr>
+    <a:masterClrMapping/>
+  </p:clrMapOvr>
+</p:sld>
+</file>
+
+<file path=ppt/slides/slide11.xml><?xml version="1.0" encoding="utf-8"?>
+<p:sld xmlns:a="http://schemas.openxmlformats.org/drawingml/2006/main" xmlns:r="http://schemas.openxmlformats.org/officeDocument/2006/relationships" xmlns:p="http://schemas.openxmlformats.org/presentationml/2006/main">
+  <p:cSld>
+    <p:spTree>
+      <p:nvGrpSpPr>
+        <p:cNvPr id="1" name=""/>
+        <p:cNvGrpSpPr/>
+        <p:nvPr/>
+      </p:nvGrpSpPr>
+      <p:grpSpPr>
+        <a:xfrm>
+          <a:off x="0" y="0"/>
+          <a:ext cx="0" cy="0"/>
+          <a:chOff x="0" y="0"/>
+          <a:chExt cx="0" cy="0"/>
+        </a:xfrm>
+      </p:grpSpPr>
+      <p:sp>
+        <p:nvSpPr>
+          <p:cNvPr id="2" name="Title 1">
+            <a:extLst>
+              <a:ext uri="{FF2B5EF4-FFF2-40B4-BE49-F238E27FC236}">
                 <a16:creationId xmlns:a16="http://schemas.microsoft.com/office/drawing/2014/main" id="{FC37A828-8C0A-4E38-A89F-8D5C85955CBB}"/>
               </a:ext>
             </a:extLst>
@@ -3544,7 +4400,7 @@
           <a:p>
             <a:r>
               <a:rPr lang="bs-Latn-BA" dirty="0"/>
-              <a:t>Problem i cilj</a:t>
+              <a:t>SADRŽAJ:</a:t>
             </a:r>
           </a:p>
         </p:txBody>
@@ -3562,18 +4418,95 @@
             <a:spLocks noGrp="1"/>
           </p:cNvSpPr>
           <p:nvPr>
-            <p:ph idx="1"/>
-          </p:nvPr>
-        </p:nvSpPr>
-        <p:spPr/>
-        <p:txBody>
-          <a:bodyPr/>
-          <a:lstStyle/>
-          <a:p>
+            <p:ph sz="half" idx="1"/>
+          </p:nvPr>
+        </p:nvSpPr>
+        <p:spPr/>
+        <p:txBody>
+          <a:bodyPr>
+            <a:normAutofit/>
+          </a:bodyPr>
+          <a:lstStyle/>
+          <a:p>
+            <a:pPr marL="0" indent="0">
+              <a:buNone/>
+            </a:pPr>
             <a:r>
               <a:rPr lang="bs-Latn-BA" dirty="0"/>
-              <a:t>U ovom projektu bavila sam se klasifikacijom antimikrobnih peptida primjenom metoda strojnog učenja. Odabrala sam ovu temu zato što je posljednjih godina sve veća otpornost bakterija na postojeće antibiotike, zbog čega je potrebno razvijati nove načine liječenja. Antimikrobni peptidi prirodne molekule koje mogu djelovati protiv bakterija, gljivica i drugih mikroorganizama. Cilj mog projekta bio je razviti model strojnog učenja koji će na temelju bioinformatičkih značajki razlikovati antimikrobni peptid od predstavljati neantimikrobnih peptida.</a:t>
-            </a:r>
+              <a:t>📌 Motivacija i cilj</a:t>
+            </a:r>
+          </a:p>
+          <a:p>
+            <a:pPr marL="0" indent="0">
+              <a:buNone/>
+            </a:pPr>
+            <a:r>
+              <a:rPr lang="bs-Latn-BA" dirty="0"/>
+              <a:t>📌 Skup podataka</a:t>
+            </a:r>
+          </a:p>
+          <a:p>
+            <a:pPr marL="0" indent="0">
+              <a:buNone/>
+            </a:pPr>
+            <a:r>
+              <a:rPr lang="bs-Latn-BA" dirty="0"/>
+              <a:t>📌 Bioinformatičke značajke</a:t>
+            </a:r>
+          </a:p>
+        </p:txBody>
+      </p:sp>
+      <p:sp>
+        <p:nvSpPr>
+          <p:cNvPr id="4" name="Content Placeholder 3">
+            <a:extLst>
+              <a:ext uri="{FF2B5EF4-FFF2-40B4-BE49-F238E27FC236}">
+                <a16:creationId xmlns:a16="http://schemas.microsoft.com/office/drawing/2014/main" id="{1A2FE1EF-7C0F-41D4-91AF-6CC46C57B94C}"/>
+              </a:ext>
+            </a:extLst>
+          </p:cNvPr>
+          <p:cNvSpPr>
+            <a:spLocks noGrp="1"/>
+          </p:cNvSpPr>
+          <p:nvPr>
+            <p:ph sz="half" idx="2"/>
+          </p:nvPr>
+        </p:nvSpPr>
+        <p:spPr/>
+        <p:txBody>
+          <a:bodyPr>
+            <a:normAutofit/>
+          </a:bodyPr>
+          <a:lstStyle/>
+          <a:p>
+            <a:pPr marL="0" indent="0">
+              <a:buNone/>
+            </a:pPr>
+            <a:r>
+              <a:rPr lang="bs-Latn-BA" dirty="0"/>
+              <a:t>📌 Modeliranje</a:t>
+            </a:r>
+          </a:p>
+          <a:p>
+            <a:pPr marL="0" indent="0">
+              <a:buNone/>
+            </a:pPr>
+            <a:r>
+              <a:rPr lang="bs-Latn-BA" dirty="0"/>
+              <a:t>📌 Rezultati</a:t>
+            </a:r>
+          </a:p>
+          <a:p>
+            <a:pPr marL="0" indent="0">
+              <a:buNone/>
+            </a:pPr>
+            <a:r>
+              <a:rPr lang="bs-Latn-BA" dirty="0"/>
+              <a:t>📌 Zaključak</a:t>
+            </a:r>
+          </a:p>
+          <a:p>
+            <a:endParaRPr lang="bs-Latn-BA" dirty="0"/>
           </a:p>
         </p:txBody>
       </p:sp>
@@ -3612,6 +4545,192 @@
           <p:cNvPr id="2" name="Title 1">
             <a:extLst>
               <a:ext uri="{FF2B5EF4-FFF2-40B4-BE49-F238E27FC236}">
+                <a16:creationId xmlns:a16="http://schemas.microsoft.com/office/drawing/2014/main" id="{672FC1B9-5EC9-470E-8A7A-2C8F6721F771}"/>
+              </a:ext>
+            </a:extLst>
+          </p:cNvPr>
+          <p:cNvSpPr>
+            <a:spLocks noGrp="1"/>
+          </p:cNvSpPr>
+          <p:nvPr>
+            <p:ph type="title"/>
+          </p:nvPr>
+        </p:nvSpPr>
+        <p:spPr/>
+        <p:txBody>
+          <a:bodyPr/>
+          <a:lstStyle/>
+          <a:p>
+            <a:r>
+              <a:rPr lang="bs-Latn-BA" dirty="0"/>
+              <a:t>MOTIVACIJA I CILJ</a:t>
+            </a:r>
+          </a:p>
+        </p:txBody>
+      </p:sp>
+      <p:sp>
+        <p:nvSpPr>
+          <p:cNvPr id="3" name="Content Placeholder 2">
+            <a:extLst>
+              <a:ext uri="{FF2B5EF4-FFF2-40B4-BE49-F238E27FC236}">
+                <a16:creationId xmlns:a16="http://schemas.microsoft.com/office/drawing/2014/main" id="{0211233D-813E-424B-9283-191BBF648682}"/>
+              </a:ext>
+            </a:extLst>
+          </p:cNvPr>
+          <p:cNvSpPr>
+            <a:spLocks noGrp="1"/>
+          </p:cNvSpPr>
+          <p:nvPr>
+            <p:ph sz="half" idx="1"/>
+          </p:nvPr>
+        </p:nvSpPr>
+        <p:spPr>
+          <a:xfrm>
+            <a:off x="2118360" y="2800985"/>
+            <a:ext cx="1844040" cy="1755775"/>
+          </a:xfrm>
+        </p:spPr>
+        <p:txBody>
+          <a:bodyPr>
+            <a:normAutofit/>
+          </a:bodyPr>
+          <a:lstStyle/>
+          <a:p>
+            <a:pPr marL="0" indent="0">
+              <a:buNone/>
+            </a:pPr>
+            <a:r>
+              <a:rPr lang="bs-Latn-BA" sz="9600" dirty="0"/>
+              <a:t>🦠 </a:t>
+            </a:r>
+          </a:p>
+        </p:txBody>
+      </p:sp>
+      <p:sp>
+        <p:nvSpPr>
+          <p:cNvPr id="4" name="Content Placeholder 3">
+            <a:extLst>
+              <a:ext uri="{FF2B5EF4-FFF2-40B4-BE49-F238E27FC236}">
+                <a16:creationId xmlns:a16="http://schemas.microsoft.com/office/drawing/2014/main" id="{1A2FE1EF-7C0F-41D4-91AF-6CC46C57B94C}"/>
+              </a:ext>
+            </a:extLst>
+          </p:cNvPr>
+          <p:cNvSpPr>
+            <a:spLocks noGrp="1"/>
+          </p:cNvSpPr>
+          <p:nvPr>
+            <p:ph sz="half" idx="2"/>
+          </p:nvPr>
+        </p:nvSpPr>
+        <p:spPr>
+          <a:xfrm>
+            <a:off x="5516882" y="1690688"/>
+            <a:ext cx="5425440" cy="4483735"/>
+          </a:xfrm>
+        </p:spPr>
+        <p:txBody>
+          <a:bodyPr>
+            <a:normAutofit/>
+          </a:bodyPr>
+          <a:lstStyle/>
+          <a:p>
+            <a:r>
+              <a:rPr lang="bs-Latn-BA" b="1" dirty="0"/>
+              <a:t>Zašto antimikrobni peptidi?</a:t>
+            </a:r>
+          </a:p>
+          <a:p>
+            <a:pPr marL="0" indent="0">
+              <a:buNone/>
+            </a:pPr>
+            <a:r>
+              <a:rPr lang="bs-Latn-BA" dirty="0"/>
+              <a:t>✔ otpornost na bakterije</a:t>
+            </a:r>
+          </a:p>
+          <a:p>
+            <a:pPr marL="0" indent="0">
+              <a:buNone/>
+            </a:pPr>
+            <a:r>
+              <a:rPr lang="bs-Latn-BA" dirty="0"/>
+              <a:t>✔ prirodna obrana organizma</a:t>
+            </a:r>
+          </a:p>
+          <a:p>
+            <a:pPr marL="0" indent="0">
+              <a:buNone/>
+            </a:pPr>
+            <a:r>
+              <a:rPr lang="bs-Latn-BA" dirty="0"/>
+              <a:t>✔ mogućnost primjene strojnog učenja</a:t>
+            </a:r>
+          </a:p>
+          <a:p>
+            <a:pPr marL="0" indent="0">
+              <a:buNone/>
+            </a:pPr>
+            <a:endParaRPr lang="bs-Latn-BA" dirty="0"/>
+          </a:p>
+          <a:p>
+            <a:pPr marL="0" indent="0">
+              <a:buNone/>
+            </a:pPr>
+            <a:r>
+              <a:rPr lang="bs-Latn-BA" b="1" dirty="0"/>
+              <a:t>Cilj projekta</a:t>
+            </a:r>
+            <a:endParaRPr lang="bs-Latn-BA" dirty="0"/>
+          </a:p>
+          <a:p>
+            <a:r>
+              <a:rPr lang="bs-Latn-BA" dirty="0"/>
+              <a:t>Razlikovati AMP i ne-AMP peptid.</a:t>
+            </a:r>
+          </a:p>
+          <a:p>
+            <a:pPr marL="0" indent="0">
+              <a:buNone/>
+            </a:pPr>
+            <a:endParaRPr lang="bs-Latn-BA" dirty="0"/>
+          </a:p>
+        </p:txBody>
+      </p:sp>
+    </p:spTree>
+    <p:extLst>
+      <p:ext uri="{BB962C8B-B14F-4D97-AF65-F5344CB8AC3E}">
+        <p14:creationId xmlns:p14="http://schemas.microsoft.com/office/powerpoint/2010/main" val="3115804253"/>
+      </p:ext>
+    </p:extLst>
+  </p:cSld>
+  <p:clrMapOvr>
+    <a:masterClrMapping/>
+  </p:clrMapOvr>
+</p:sld>
+</file>
+
+<file path=ppt/slides/slide4.xml><?xml version="1.0" encoding="utf-8"?>
+<p:sld xmlns:a="http://schemas.openxmlformats.org/drawingml/2006/main" xmlns:r="http://schemas.openxmlformats.org/officeDocument/2006/relationships" xmlns:p="http://schemas.openxmlformats.org/presentationml/2006/main">
+  <p:cSld>
+    <p:spTree>
+      <p:nvGrpSpPr>
+        <p:cNvPr id="1" name=""/>
+        <p:cNvGrpSpPr/>
+        <p:nvPr/>
+      </p:nvGrpSpPr>
+      <p:grpSpPr>
+        <a:xfrm>
+          <a:off x="0" y="0"/>
+          <a:ext cx="0" cy="0"/>
+          <a:chOff x="0" y="0"/>
+          <a:chExt cx="0" cy="0"/>
+        </a:xfrm>
+      </p:grpSpPr>
+      <p:sp>
+        <p:nvSpPr>
+          <p:cNvPr id="2" name="Title 1">
+            <a:extLst>
+              <a:ext uri="{FF2B5EF4-FFF2-40B4-BE49-F238E27FC236}">
                 <a16:creationId xmlns:a16="http://schemas.microsoft.com/office/drawing/2014/main" id="{E555C528-01C7-497E-892F-D6EC4D276DBD}"/>
               </a:ext>
             </a:extLst>
@@ -3708,7 +4827,7 @@
 </p:sld>
 </file>
 
-<file path=ppt/slides/slide4.xml><?xml version="1.0" encoding="utf-8"?>
+<file path=ppt/slides/slide5.xml><?xml version="1.0" encoding="utf-8"?>
 <p:sld xmlns:a="http://schemas.openxmlformats.org/drawingml/2006/main" xmlns:r="http://schemas.openxmlformats.org/officeDocument/2006/relationships" xmlns:p="http://schemas.openxmlformats.org/presentationml/2006/main">
   <p:cSld>
     <p:spTree>
@@ -3825,7 +4944,7 @@
 </p:sld>
 </file>
 
-<file path=ppt/slides/slide5.xml><?xml version="1.0" encoding="utf-8"?>
+<file path=ppt/slides/slide6.xml><?xml version="1.0" encoding="utf-8"?>
 <p:sld xmlns:a="http://schemas.openxmlformats.org/drawingml/2006/main" xmlns:r="http://schemas.openxmlformats.org/officeDocument/2006/relationships" xmlns:p="http://schemas.openxmlformats.org/presentationml/2006/main">
   <p:cSld>
     <p:spTree>
@@ -4027,7 +5146,7 @@
 </p:sld>
 </file>
 
-<file path=ppt/slides/slide6.xml><?xml version="1.0" encoding="utf-8"?>
+<file path=ppt/slides/slide7.xml><?xml version="1.0" encoding="utf-8"?>
 <p:sld xmlns:a="http://schemas.openxmlformats.org/drawingml/2006/main" xmlns:r="http://schemas.openxmlformats.org/officeDocument/2006/relationships" xmlns:p="http://schemas.openxmlformats.org/presentationml/2006/main">
   <p:cSld>
     <p:spTree>
@@ -4614,7 +5733,7 @@
 </p:sld>
 </file>
 
-<file path=ppt/slides/slide7.xml><?xml version="1.0" encoding="utf-8"?>
+<file path=ppt/slides/slide8.xml><?xml version="1.0" encoding="utf-8"?>
 <p:sld xmlns:a="http://schemas.openxmlformats.org/drawingml/2006/main" xmlns:r="http://schemas.openxmlformats.org/officeDocument/2006/relationships" xmlns:p="http://schemas.openxmlformats.org/presentationml/2006/main">
   <p:cSld>
     <p:spTree>
@@ -4987,7 +6106,7 @@
 </p:sld>
 </file>
 
-<file path=ppt/slides/slide8.xml><?xml version="1.0" encoding="utf-8"?>
+<file path=ppt/slides/slide9.xml><?xml version="1.0" encoding="utf-8"?>
 <p:sld xmlns:a="http://schemas.openxmlformats.org/drawingml/2006/main" xmlns:r="http://schemas.openxmlformats.org/officeDocument/2006/relationships" xmlns:p="http://schemas.openxmlformats.org/presentationml/2006/main">
   <p:cSld>
     <p:spTree>
@@ -5104,195 +6223,6 @@
     <p:extLst>
       <p:ext uri="{BB962C8B-B14F-4D97-AF65-F5344CB8AC3E}">
         <p14:creationId xmlns:p14="http://schemas.microsoft.com/office/powerpoint/2010/main" val="827978955"/>
-      </p:ext>
-    </p:extLst>
-  </p:cSld>
-  <p:clrMapOvr>
-    <a:masterClrMapping/>
-  </p:clrMapOvr>
-</p:sld>
-</file>
-
-<file path=ppt/slides/slide9.xml><?xml version="1.0" encoding="utf-8"?>
-<p:sld xmlns:a="http://schemas.openxmlformats.org/drawingml/2006/main" xmlns:r="http://schemas.openxmlformats.org/officeDocument/2006/relationships" xmlns:p="http://schemas.openxmlformats.org/presentationml/2006/main">
-  <p:cSld>
-    <p:spTree>
-      <p:nvGrpSpPr>
-        <p:cNvPr id="1" name=""/>
-        <p:cNvGrpSpPr/>
-        <p:nvPr/>
-      </p:nvGrpSpPr>
-      <p:grpSpPr>
-        <a:xfrm>
-          <a:off x="0" y="0"/>
-          <a:ext cx="0" cy="0"/>
-          <a:chOff x="0" y="0"/>
-          <a:chExt cx="0" cy="0"/>
-        </a:xfrm>
-      </p:grpSpPr>
-      <p:sp>
-        <p:nvSpPr>
-          <p:cNvPr id="2" name="Title 1">
-            <a:extLst>
-              <a:ext uri="{FF2B5EF4-FFF2-40B4-BE49-F238E27FC236}">
-                <a16:creationId xmlns:a16="http://schemas.microsoft.com/office/drawing/2014/main" id="{99F40CC0-509D-401D-8390-D9C19BC73821}"/>
-              </a:ext>
-            </a:extLst>
-          </p:cNvPr>
-          <p:cNvSpPr>
-            <a:spLocks noGrp="1"/>
-          </p:cNvSpPr>
-          <p:nvPr>
-            <p:ph type="title"/>
-          </p:nvPr>
-        </p:nvSpPr>
-        <p:spPr/>
-        <p:txBody>
-          <a:bodyPr/>
-          <a:lstStyle/>
-          <a:p>
-            <a:r>
-              <a:rPr lang="bs-Latn-BA" dirty="0"/>
-              <a:t>Zaključak</a:t>
-            </a:r>
-          </a:p>
-        </p:txBody>
-      </p:sp>
-      <p:sp>
-        <p:nvSpPr>
-          <p:cNvPr id="12" name="Content Placeholder 11">
-            <a:extLst>
-              <a:ext uri="{FF2B5EF4-FFF2-40B4-BE49-F238E27FC236}">
-                <a16:creationId xmlns:a16="http://schemas.microsoft.com/office/drawing/2014/main" id="{9352BE13-6B85-49AC-9FE3-0EFAF02B6A25}"/>
-              </a:ext>
-            </a:extLst>
-          </p:cNvPr>
-          <p:cNvSpPr>
-            <a:spLocks noGrp="1"/>
-          </p:cNvSpPr>
-          <p:nvPr>
-            <p:ph sz="half" idx="1"/>
-          </p:nvPr>
-        </p:nvSpPr>
-        <p:spPr/>
-        <p:txBody>
-          <a:bodyPr/>
-          <a:lstStyle/>
-          <a:p>
-            <a:r>
-              <a:rPr lang="bs-Latn-BA" sz="1800" b="1" dirty="0">
-                <a:effectLst/>
-                <a:latin typeface="Calibri" panose="020F0502020204030204" pitchFamily="34" charset="0"/>
-                <a:ea typeface="Calibri" panose="020F0502020204030204" pitchFamily="34" charset="0"/>
-                <a:cs typeface="Times New Roman" panose="02020603050405020304" pitchFamily="18" charset="0"/>
-              </a:rPr>
-              <a:t>Za kraj mogu zaključiti da je cilj ovog projekta uspješno ostvaren. Razvila sam model strojnog učenja koji razlikuje antimikrobne od neantimikrobnih peptida na temelju bioinformatičkih značajki. Oba modela ostvarila su vrlo dobre rezultate, dok je Random Forest bio nešto uspješniji od SVM-a. Analiza važnosti značajki pokazala je da je neto naboj najvažnije svojstvo za klasifikaciju peptida. U budućnosti bi se projekt mogao proširiti korištenjem dodatnih bioinformatičkih značajki ili naprednijih modela strojnog učenja."</a:t>
-            </a:r>
-            <a:endParaRPr lang="bs-Latn-BA" dirty="0"/>
-          </a:p>
-        </p:txBody>
-      </p:sp>
-      <p:sp>
-        <p:nvSpPr>
-          <p:cNvPr id="4" name="Content Placeholder 3">
-            <a:extLst>
-              <a:ext uri="{FF2B5EF4-FFF2-40B4-BE49-F238E27FC236}">
-                <a16:creationId xmlns:a16="http://schemas.microsoft.com/office/drawing/2014/main" id="{91457B41-5DFC-4D11-8F7C-B3DE3045429F}"/>
-              </a:ext>
-            </a:extLst>
-          </p:cNvPr>
-          <p:cNvSpPr>
-            <a:spLocks noGrp="1"/>
-          </p:cNvSpPr>
-          <p:nvPr>
-            <p:ph sz="half" idx="2"/>
-          </p:nvPr>
-        </p:nvSpPr>
-        <p:spPr/>
-        <p:txBody>
-          <a:bodyPr/>
-          <a:lstStyle/>
-          <a:p>
-            <a:pPr marL="342900" lvl="0" indent="-342900">
-              <a:buSzPts val="1000"/>
-              <a:buFont typeface="Symbol" panose="05050102010706020507" pitchFamily="18" charset="2"/>
-              <a:buChar char=""/>
-              <a:tabLst>
-                <a:tab pos="457200" algn="l"/>
-              </a:tabLst>
-            </a:pPr>
-            <a:r>
-              <a:rPr lang="bs-Latn-BA" sz="1800" dirty="0">
-                <a:effectLst/>
-                <a:latin typeface="Times New Roman" panose="02020603050405020304" pitchFamily="18" charset="0"/>
-                <a:ea typeface="Times New Roman" panose="02020603050405020304" pitchFamily="18" charset="0"/>
-              </a:rPr>
-              <a:t>Razvijen model za klasifikaciju AMP i non-AMP peptida</a:t>
-            </a:r>
-          </a:p>
-          <a:p>
-            <a:pPr marL="342900" lvl="0" indent="-342900">
-              <a:buSzPts val="1000"/>
-              <a:buFont typeface="Symbol" panose="05050102010706020507" pitchFamily="18" charset="2"/>
-              <a:buChar char=""/>
-              <a:tabLst>
-                <a:tab pos="457200" algn="l"/>
-              </a:tabLst>
-            </a:pPr>
-            <a:r>
-              <a:rPr lang="bs-Latn-BA" sz="1800" dirty="0">
-                <a:effectLst/>
-                <a:latin typeface="Times New Roman" panose="02020603050405020304" pitchFamily="18" charset="0"/>
-                <a:ea typeface="Times New Roman" panose="02020603050405020304" pitchFamily="18" charset="0"/>
-              </a:rPr>
-              <a:t>Random Forest ostvario najbolje rezultate</a:t>
-            </a:r>
-          </a:p>
-          <a:p>
-            <a:pPr marL="342900" lvl="0" indent="-342900">
-              <a:buSzPts val="1000"/>
-              <a:buFont typeface="Symbol" panose="05050102010706020507" pitchFamily="18" charset="2"/>
-              <a:buChar char=""/>
-              <a:tabLst>
-                <a:tab pos="457200" algn="l"/>
-              </a:tabLst>
-            </a:pPr>
-            <a:r>
-              <a:rPr lang="bs-Latn-BA" sz="1800" dirty="0">
-                <a:effectLst/>
-                <a:latin typeface="Times New Roman" panose="02020603050405020304" pitchFamily="18" charset="0"/>
-                <a:ea typeface="Times New Roman" panose="02020603050405020304" pitchFamily="18" charset="0"/>
-              </a:rPr>
-              <a:t>Neto naboj bio najvažnija značajka</a:t>
-            </a:r>
-          </a:p>
-          <a:p>
-            <a:pPr marL="342900" lvl="0" indent="-342900">
-              <a:buSzPts val="1000"/>
-              <a:buFont typeface="Symbol" panose="05050102010706020507" pitchFamily="18" charset="2"/>
-              <a:buChar char=""/>
-              <a:tabLst>
-                <a:tab pos="457200" algn="l"/>
-              </a:tabLst>
-            </a:pPr>
-            <a:r>
-              <a:rPr lang="bs-Latn-BA" sz="1800" dirty="0">
-                <a:effectLst/>
-                <a:latin typeface="Times New Roman" panose="02020603050405020304" pitchFamily="18" charset="0"/>
-                <a:ea typeface="Times New Roman" panose="02020603050405020304" pitchFamily="18" charset="0"/>
-              </a:rPr>
-              <a:t>Mogućnost proširenja dodatnim značajkama i modelima</a:t>
-            </a:r>
-          </a:p>
-          <a:p>
-            <a:endParaRPr lang="bs-Latn-BA" dirty="0"/>
-          </a:p>
-        </p:txBody>
-      </p:sp>
-    </p:spTree>
-    <p:extLst>
-      <p:ext uri="{BB962C8B-B14F-4D97-AF65-F5344CB8AC3E}">
-        <p14:creationId xmlns:p14="http://schemas.microsoft.com/office/powerpoint/2010/main" val="3231986733"/>
       </p:ext>
     </p:extLst>
   </p:cSld>
@@ -5595,4 +6525,299 @@
     </a:ext>
   </a:extLst>
 </a:theme>
+</file>
+
+<file path=ppt/theme/theme2.xml><?xml version="1.0" encoding="utf-8"?>
+<a:theme xmlns:a="http://schemas.openxmlformats.org/drawingml/2006/main" name="Office Theme">
+  <a:themeElements>
+    <a:clrScheme name="Office">
+      <a:dk1>
+        <a:sysClr val="windowText" lastClr="000000"/>
+      </a:dk1>
+      <a:lt1>
+        <a:sysClr val="window" lastClr="FFFFFF"/>
+      </a:lt1>
+      <a:dk2>
+        <a:srgbClr val="44546A"/>
+      </a:dk2>
+      <a:lt2>
+        <a:srgbClr val="E7E6E6"/>
+      </a:lt2>
+      <a:accent1>
+        <a:srgbClr val="4472C4"/>
+      </a:accent1>
+      <a:accent2>
+        <a:srgbClr val="ED7D31"/>
+      </a:accent2>
+      <a:accent3>
+        <a:srgbClr val="A5A5A5"/>
+      </a:accent3>
+      <a:accent4>
+        <a:srgbClr val="FFC000"/>
+      </a:accent4>
+      <a:accent5>
+        <a:srgbClr val="5B9BD5"/>
+      </a:accent5>
+      <a:accent6>
+        <a:srgbClr val="70AD47"/>
+      </a:accent6>
+      <a:hlink>
+        <a:srgbClr val="0563C1"/>
+      </a:hlink>
+      <a:folHlink>
+        <a:srgbClr val="954F72"/>
+      </a:folHlink>
+    </a:clrScheme>
+    <a:fontScheme name="Office">
+      <a:majorFont>
+        <a:latin typeface="Calibri Light" panose="020F0302020204030204"/>
+        <a:ea typeface=""/>
+        <a:cs typeface=""/>
+        <a:font script="Jpan" typeface="游ゴシック Light"/>
+        <a:font script="Hang" typeface="맑은 고딕"/>
+        <a:font script="Hans" typeface="等线 Light"/>
+        <a:font script="Hant" typeface="新細明體"/>
+        <a:font script="Arab" typeface="Times New Roman"/>
+        <a:font script="Hebr" typeface="Times New Roman"/>
+        <a:font script="Thai" typeface="Angsana New"/>
+        <a:font script="Ethi" typeface="Nyala"/>
+        <a:font script="Beng" typeface="Vrinda"/>
+        <a:font script="Gujr" typeface="Shruti"/>
+        <a:font script="Khmr" typeface="MoolBoran"/>
+        <a:font script="Knda" typeface="Tunga"/>
+        <a:font script="Guru" typeface="Raavi"/>
+        <a:font script="Cans" typeface="Euphemia"/>
+        <a:font script="Cher" typeface="Plantagenet Cherokee"/>
+        <a:font script="Yiii" typeface="Microsoft Yi Baiti"/>
+        <a:font script="Tibt" typeface="Microsoft Himalaya"/>
+        <a:font script="Thaa" typeface="MV Boli"/>
+        <a:font script="Deva" typeface="Mangal"/>
+        <a:font script="Telu" typeface="Gautami"/>
+        <a:font script="Taml" typeface="Latha"/>
+        <a:font script="Syrc" typeface="Estrangelo Edessa"/>
+        <a:font script="Orya" typeface="Kalinga"/>
+        <a:font script="Mlym" typeface="Kartika"/>
+        <a:font script="Laoo" typeface="DokChampa"/>
+        <a:font script="Sinh" typeface="Iskoola Pota"/>
+        <a:font script="Mong" typeface="Mongolian Baiti"/>
+        <a:font script="Viet" typeface="Times New Roman"/>
+        <a:font script="Uigh" typeface="Microsoft Uighur"/>
+        <a:font script="Geor" typeface="Sylfaen"/>
+        <a:font script="Armn" typeface="Arial"/>
+        <a:font script="Bugi" typeface="Leelawadee UI"/>
+        <a:font script="Bopo" typeface="Microsoft JhengHei"/>
+        <a:font script="Java" typeface="Javanese Text"/>
+        <a:font script="Lisu" typeface="Segoe UI"/>
+        <a:font script="Mymr" typeface="Myanmar Text"/>
+        <a:font script="Nkoo" typeface="Ebrima"/>
+        <a:font script="Olck" typeface="Nirmala UI"/>
+        <a:font script="Osma" typeface="Ebrima"/>
+        <a:font script="Phag" typeface="Phagspa"/>
+        <a:font script="Syrn" typeface="Estrangelo Edessa"/>
+        <a:font script="Syrj" typeface="Estrangelo Edessa"/>
+        <a:font script="Syre" typeface="Estrangelo Edessa"/>
+        <a:font script="Sora" typeface="Nirmala UI"/>
+        <a:font script="Tale" typeface="Microsoft Tai Le"/>
+        <a:font script="Talu" typeface="Microsoft New Tai Lue"/>
+        <a:font script="Tfng" typeface="Ebrima"/>
+      </a:majorFont>
+      <a:minorFont>
+        <a:latin typeface="Calibri" panose="020F0502020204030204"/>
+        <a:ea typeface=""/>
+        <a:cs typeface=""/>
+        <a:font script="Jpan" typeface="游ゴシック"/>
+        <a:font script="Hang" typeface="맑은 고딕"/>
+        <a:font script="Hans" typeface="等线"/>
+        <a:font script="Hant" typeface="新細明體"/>
+        <a:font script="Arab" typeface="Arial"/>
+        <a:font script="Hebr" typeface="Arial"/>
+        <a:font script="Thai" typeface="Cordia New"/>
+        <a:font script="Ethi" typeface="Nyala"/>
+        <a:font script="Beng" typeface="Vrinda"/>
+        <a:font script="Gujr" typeface="Shruti"/>
+        <a:font script="Khmr" typeface="DaunPenh"/>
+        <a:font script="Knda" typeface="Tunga"/>
+        <a:font script="Guru" typeface="Raavi"/>
+        <a:font script="Cans" typeface="Euphemia"/>
+        <a:font script="Cher" typeface="Plantagenet Cherokee"/>
+        <a:font script="Yiii" typeface="Microsoft Yi Baiti"/>
+        <a:font script="Tibt" typeface="Microsoft Himalaya"/>
+        <a:font script="Thaa" typeface="MV Boli"/>
+        <a:font script="Deva" typeface="Mangal"/>
+        <a:font script="Telu" typeface="Gautami"/>
+        <a:font script="Taml" typeface="Latha"/>
+        <a:font script="Syrc" typeface="Estrangelo Edessa"/>
+        <a:font script="Orya" typeface="Kalinga"/>
+        <a:font script="Mlym" typeface="Kartika"/>
+        <a:font script="Laoo" typeface="DokChampa"/>
+        <a:font script="Sinh" typeface="Iskoola Pota"/>
+        <a:font script="Mong" typeface="Mongolian Baiti"/>
+        <a:font script="Viet" typeface="Arial"/>
+        <a:font script="Uigh" typeface="Microsoft Uighur"/>
+        <a:font script="Geor" typeface="Sylfaen"/>
+        <a:font script="Armn" typeface="Arial"/>
+        <a:font script="Bugi" typeface="Leelawadee UI"/>
+        <a:font script="Bopo" typeface="Microsoft JhengHei"/>
+        <a:font script="Java" typeface="Javanese Text"/>
+        <a:font script="Lisu" typeface="Segoe UI"/>
+        <a:font script="Mymr" typeface="Myanmar Text"/>
+        <a:font script="Nkoo" typeface="Ebrima"/>
+        <a:font script="Olck" typeface="Nirmala UI"/>
+        <a:font script="Osma" typeface="Ebrima"/>
+        <a:font script="Phag" typeface="Phagspa"/>
+        <a:font script="Syrn" typeface="Estrangelo Edessa"/>
+        <a:font script="Syrj" typeface="Estrangelo Edessa"/>
+        <a:font script="Syre" typeface="Estrangelo Edessa"/>
+        <a:font script="Sora" typeface="Nirmala UI"/>
+        <a:font script="Tale" typeface="Microsoft Tai Le"/>
+        <a:font script="Talu" typeface="Microsoft New Tai Lue"/>
+        <a:font script="Tfng" typeface="Ebrima"/>
+      </a:minorFont>
+    </a:fontScheme>
+    <a:fmtScheme name="Office">
+      <a:fillStyleLst>
+        <a:solidFill>
+          <a:schemeClr val="phClr"/>
+        </a:solidFill>
+        <a:gradFill rotWithShape="1">
+          <a:gsLst>
+            <a:gs pos="0">
+              <a:schemeClr val="phClr">
+                <a:lumMod val="110000"/>
+                <a:satMod val="105000"/>
+                <a:tint val="67000"/>
+              </a:schemeClr>
+            </a:gs>
+            <a:gs pos="50000">
+              <a:schemeClr val="phClr">
+                <a:lumMod val="105000"/>
+                <a:satMod val="103000"/>
+                <a:tint val="73000"/>
+              </a:schemeClr>
+            </a:gs>
+            <a:gs pos="100000">
+              <a:schemeClr val="phClr">
+                <a:lumMod val="105000"/>
+                <a:satMod val="109000"/>
+                <a:tint val="81000"/>
+              </a:schemeClr>
+            </a:gs>
+          </a:gsLst>
+          <a:lin ang="5400000" scaled="0"/>
+        </a:gradFill>
+        <a:gradFill rotWithShape="1">
+          <a:gsLst>
+            <a:gs pos="0">
+              <a:schemeClr val="phClr">
+                <a:satMod val="103000"/>
+                <a:lumMod val="102000"/>
+                <a:tint val="94000"/>
+              </a:schemeClr>
+            </a:gs>
+            <a:gs pos="50000">
+              <a:schemeClr val="phClr">
+                <a:satMod val="110000"/>
+                <a:lumMod val="100000"/>
+                <a:shade val="100000"/>
+              </a:schemeClr>
+            </a:gs>
+            <a:gs pos="100000">
+              <a:schemeClr val="phClr">
+                <a:lumMod val="99000"/>
+                <a:satMod val="120000"/>
+                <a:shade val="78000"/>
+              </a:schemeClr>
+            </a:gs>
+          </a:gsLst>
+          <a:lin ang="5400000" scaled="0"/>
+        </a:gradFill>
+      </a:fillStyleLst>
+      <a:lnStyleLst>
+        <a:ln w="6350" cap="flat" cmpd="sng" algn="ctr">
+          <a:solidFill>
+            <a:schemeClr val="phClr"/>
+          </a:solidFill>
+          <a:prstDash val="solid"/>
+          <a:miter lim="800000"/>
+        </a:ln>
+        <a:ln w="12700" cap="flat" cmpd="sng" algn="ctr">
+          <a:solidFill>
+            <a:schemeClr val="phClr"/>
+          </a:solidFill>
+          <a:prstDash val="solid"/>
+          <a:miter lim="800000"/>
+        </a:ln>
+        <a:ln w="19050" cap="flat" cmpd="sng" algn="ctr">
+          <a:solidFill>
+            <a:schemeClr val="phClr"/>
+          </a:solidFill>
+          <a:prstDash val="solid"/>
+          <a:miter lim="800000"/>
+        </a:ln>
+      </a:lnStyleLst>
+      <a:effectStyleLst>
+        <a:effectStyle>
+          <a:effectLst/>
+        </a:effectStyle>
+        <a:effectStyle>
+          <a:effectLst/>
+        </a:effectStyle>
+        <a:effectStyle>
+          <a:effectLst>
+            <a:outerShdw blurRad="57150" dist="19050" dir="5400000" algn="ctr" rotWithShape="0">
+              <a:srgbClr val="000000">
+                <a:alpha val="63000"/>
+              </a:srgbClr>
+            </a:outerShdw>
+          </a:effectLst>
+        </a:effectStyle>
+      </a:effectStyleLst>
+      <a:bgFillStyleLst>
+        <a:solidFill>
+          <a:schemeClr val="phClr"/>
+        </a:solidFill>
+        <a:solidFill>
+          <a:schemeClr val="phClr">
+            <a:tint val="95000"/>
+            <a:satMod val="170000"/>
+          </a:schemeClr>
+        </a:solidFill>
+        <a:gradFill rotWithShape="1">
+          <a:gsLst>
+            <a:gs pos="0">
+              <a:schemeClr val="phClr">
+                <a:tint val="93000"/>
+                <a:satMod val="150000"/>
+                <a:shade val="98000"/>
+                <a:lumMod val="102000"/>
+              </a:schemeClr>
+            </a:gs>
+            <a:gs pos="50000">
+              <a:schemeClr val="phClr">
+                <a:tint val="98000"/>
+                <a:satMod val="130000"/>
+                <a:shade val="90000"/>
+                <a:lumMod val="103000"/>
+              </a:schemeClr>
+            </a:gs>
+            <a:gs pos="100000">
+              <a:schemeClr val="phClr">
+                <a:shade val="63000"/>
+                <a:satMod val="120000"/>
+              </a:schemeClr>
+            </a:gs>
+          </a:gsLst>
+          <a:lin ang="5400000" scaled="0"/>
+        </a:gradFill>
+      </a:bgFillStyleLst>
+    </a:fmtScheme>
+  </a:themeElements>
+  <a:objectDefaults/>
+  <a:extraClrSchemeLst/>
+  <a:extLst>
+    <a:ext uri="{05A4C25C-085E-4340-85A3-A5531E510DB2}">
+      <thm15:themeFamily xmlns:thm15="http://schemas.microsoft.com/office/thememl/2012/main" name="Office Theme" id="{62F939B6-93AF-4DB8-9C6B-D6C7DFDC589F}" vid="{4A3C46E8-61CC-4603-A589-7422A47A8E4A}"/>
+    </a:ext>
+  </a:extLst>
+</a:theme>
 </file>
</xml_diff>